<commit_message>
Remove top-right label from slides
Co-Authored-By: Claude Opus 5.5 <noreply@anthropic.com>
Claude-Session: https://claude.ai/code/session_018KuUK9HhcCkFfjqAcDZkbU
</commit_message>
<xml_diff>
--- a/転倒つまずき災害_安全衛生協議会.pptx
+++ b/転倒つまずき災害_安全衛生協議会.pptx
@@ -1052,46 +1052,7 @@
       </p:sp>
       <p:sp>
         <p:nvSpPr>
-          <p:cNvPr id="5" name="Text 2"/>
-          <p:cNvSpPr txBox="1"/>
-          <p:nvPr/>
-        </p:nvSpPr>
-        <p:spPr>
-          <a:xfrm>
-            <a:off x="9052560" y="256032"/>
-            <a:ext cx="2679192" cy="603504"/>
-          </a:xfrm>
-          <a:prstGeom prst="rect">
-            <a:avLst/>
-          </a:prstGeom>
-          <a:noFill/>
-          <a:ln/>
-        </p:spPr>
-        <p:txBody>
-          <a:bodyPr wrap="square" lIns="0" tIns="0" rIns="0" bIns="0" rtlCol="0" anchor="ctr"/>
-          <a:lstStyle/>
-          <a:p>
-            <a:pPr algn="r" indent="0" marL="0">
-              <a:buNone/>
-            </a:pPr>
-            <a:r>
-              <a:rPr lang="en-US" sz="1100" dirty="0">
-                <a:solidFill>
-                  <a:srgbClr val="5B616B"/>
-                </a:solidFill>
-                <a:latin typeface="Meiryo" pitchFamily="34" charset="0"/>
-                <a:ea typeface="Meiryo" pitchFamily="34" charset="-122"/>
-                <a:cs typeface="Meiryo" pitchFamily="34" charset="-120"/>
-              </a:rPr>
-              <a:t>安全衛生協議会 ｜ 建築工事</a:t>
-            </a:r>
-            <a:endParaRPr lang="en-US" sz="1100" dirty="0"/>
-          </a:p>
-        </p:txBody>
-      </p:sp>
-      <p:sp>
-        <p:nvSpPr>
-          <p:cNvPr id="6" name="Shape 3"/>
+          <p:cNvPr id="5" name="Shape 2"/>
           <p:cNvSpPr/>
           <p:nvPr/>
         </p:nvSpPr>
@@ -1113,14 +1074,53 @@
       </p:sp>
       <p:sp>
         <p:nvSpPr>
+          <p:cNvPr id="6" name="Text 3"/>
+          <p:cNvSpPr txBox="1"/>
+          <p:nvPr/>
+        </p:nvSpPr>
+        <p:spPr>
+          <a:xfrm>
+            <a:off x="731520" y="1298448"/>
+            <a:ext cx="2743200" cy="365760"/>
+          </a:xfrm>
+          <a:prstGeom prst="rect">
+            <a:avLst/>
+          </a:prstGeom>
+          <a:noFill/>
+          <a:ln/>
+        </p:spPr>
+        <p:txBody>
+          <a:bodyPr wrap="square" lIns="0" tIns="0" rIns="0" bIns="0" rtlCol="0" anchor="t"/>
+          <a:lstStyle/>
+          <a:p>
+            <a:pPr indent="0" marL="0">
+              <a:buNone/>
+            </a:pPr>
+            <a:r>
+              <a:rPr lang="en-US" sz="1400" b="1" dirty="0">
+                <a:solidFill>
+                  <a:srgbClr val="FFFFFF"/>
+                </a:solidFill>
+                <a:latin typeface="Meiryo" pitchFamily="34" charset="0"/>
+                <a:ea typeface="Meiryo" pitchFamily="34" charset="-122"/>
+                <a:cs typeface="Meiryo" pitchFamily="34" charset="-120"/>
+              </a:rPr>
+              <a:t>データで見る転倒災害</a:t>
+            </a:r>
+            <a:endParaRPr lang="en-US" sz="1400" dirty="0"/>
+          </a:p>
+        </p:txBody>
+      </p:sp>
+      <p:sp>
+        <p:nvSpPr>
           <p:cNvPr id="7" name="Text 4"/>
           <p:cNvSpPr txBox="1"/>
           <p:nvPr/>
         </p:nvSpPr>
         <p:spPr>
           <a:xfrm>
-            <a:off x="731520" y="1298448"/>
-            <a:ext cx="2743200" cy="365760"/>
+            <a:off x="731520" y="1828800"/>
+            <a:ext cx="2743200" cy="548640"/>
           </a:xfrm>
           <a:prstGeom prst="rect">
             <a:avLst/>
@@ -1136,17 +1136,17 @@
               <a:buNone/>
             </a:pPr>
             <a:r>
-              <a:rPr lang="en-US" sz="1400" b="1" dirty="0">
-                <a:solidFill>
-                  <a:srgbClr val="FFFFFF"/>
-                </a:solidFill>
-                <a:latin typeface="Meiryo" pitchFamily="34" charset="0"/>
-                <a:ea typeface="Meiryo" pitchFamily="34" charset="-122"/>
-                <a:cs typeface="Meiryo" pitchFamily="34" charset="-120"/>
-              </a:rPr>
-              <a:t>データで見る転倒災害</a:t>
-            </a:r>
-            <a:endParaRPr lang="en-US" sz="1400" dirty="0"/>
+              <a:rPr lang="en-US" sz="2800" b="1" dirty="0">
+                <a:solidFill>
+                  <a:srgbClr val="FFC20E"/>
+                </a:solidFill>
+                <a:latin typeface="Meiryo" pitchFamily="34" charset="0"/>
+                <a:ea typeface="Meiryo" pitchFamily="34" charset="-122"/>
+                <a:cs typeface="Meiryo" pitchFamily="34" charset="-120"/>
+              </a:rPr>
+              <a:t>約4件に1件</a:t>
+            </a:r>
+            <a:endParaRPr lang="en-US" sz="2800" dirty="0"/>
           </a:p>
         </p:txBody>
       </p:sp>
@@ -1158,8 +1158,8 @@
         </p:nvSpPr>
         <p:spPr>
           <a:xfrm>
-            <a:off x="731520" y="1828800"/>
-            <a:ext cx="2743200" cy="548640"/>
+            <a:off x="731520" y="2395728"/>
+            <a:ext cx="2743200" cy="731520"/>
           </a:xfrm>
           <a:prstGeom prst="rect">
             <a:avLst/>
@@ -1175,17 +1175,17 @@
               <a:buNone/>
             </a:pPr>
             <a:r>
-              <a:rPr lang="en-US" sz="2800" b="1" dirty="0">
-                <a:solidFill>
-                  <a:srgbClr val="FFC20E"/>
-                </a:solidFill>
-                <a:latin typeface="Meiryo" pitchFamily="34" charset="0"/>
-                <a:ea typeface="Meiryo" pitchFamily="34" charset="-122"/>
-                <a:cs typeface="Meiryo" pitchFamily="34" charset="-120"/>
-              </a:rPr>
-              <a:t>約4件に1件</a:t>
-            </a:r>
-            <a:endParaRPr lang="en-US" sz="2800" dirty="0"/>
+              <a:rPr lang="en-US" sz="1050" dirty="0">
+                <a:solidFill>
+                  <a:srgbClr val="D9DCE1"/>
+                </a:solidFill>
+                <a:latin typeface="Meiryo" pitchFamily="34" charset="0"/>
+                <a:ea typeface="Meiryo" pitchFamily="34" charset="-122"/>
+                <a:cs typeface="Meiryo" pitchFamily="34" charset="-120"/>
+              </a:rPr>
+              <a:t>休業4日以上の死傷災害のうち「転倒」が占める割合。事故の型別で最多（全産業）</a:t>
+            </a:r>
+            <a:endParaRPr lang="en-US" sz="1050" dirty="0"/>
           </a:p>
         </p:txBody>
       </p:sp>
@@ -1197,8 +1197,8 @@
         </p:nvSpPr>
         <p:spPr>
           <a:xfrm>
-            <a:off x="731520" y="2395728"/>
-            <a:ext cx="2743200" cy="731520"/>
+            <a:off x="731520" y="3200400"/>
+            <a:ext cx="2743200" cy="548640"/>
           </a:xfrm>
           <a:prstGeom prst="rect">
             <a:avLst/>
@@ -1214,17 +1214,17 @@
               <a:buNone/>
             </a:pPr>
             <a:r>
-              <a:rPr lang="en-US" sz="1050" dirty="0">
-                <a:solidFill>
-                  <a:srgbClr val="D9DCE1"/>
-                </a:solidFill>
-                <a:latin typeface="Meiryo" pitchFamily="34" charset="0"/>
-                <a:ea typeface="Meiryo" pitchFamily="34" charset="-122"/>
-                <a:cs typeface="Meiryo" pitchFamily="34" charset="-120"/>
-              </a:rPr>
-              <a:t>休業4日以上の死傷災害のうち「転倒」が占める割合。事故の型別で最多（全産業）</a:t>
-            </a:r>
-            <a:endParaRPr lang="en-US" sz="1050" dirty="0"/>
+              <a:rPr lang="en-US" sz="2800" b="1" dirty="0">
+                <a:solidFill>
+                  <a:srgbClr val="FFC20E"/>
+                </a:solidFill>
+                <a:latin typeface="Meiryo" pitchFamily="34" charset="0"/>
+                <a:ea typeface="Meiryo" pitchFamily="34" charset="-122"/>
+                <a:cs typeface="Meiryo" pitchFamily="34" charset="-120"/>
+              </a:rPr>
+              <a:t>約6割</a:t>
+            </a:r>
+            <a:endParaRPr lang="en-US" sz="2800" dirty="0"/>
           </a:p>
         </p:txBody>
       </p:sp>
@@ -1236,8 +1236,8 @@
         </p:nvSpPr>
         <p:spPr>
           <a:xfrm>
-            <a:off x="731520" y="3200400"/>
-            <a:ext cx="2743200" cy="548640"/>
+            <a:off x="731520" y="3767328"/>
+            <a:ext cx="2743200" cy="731520"/>
           </a:xfrm>
           <a:prstGeom prst="rect">
             <a:avLst/>
@@ -1253,17 +1253,17 @@
               <a:buNone/>
             </a:pPr>
             <a:r>
-              <a:rPr lang="en-US" sz="2800" b="1" dirty="0">
-                <a:solidFill>
-                  <a:srgbClr val="FFC20E"/>
-                </a:solidFill>
-                <a:latin typeface="Meiryo" pitchFamily="34" charset="0"/>
-                <a:ea typeface="Meiryo" pitchFamily="34" charset="-122"/>
-                <a:cs typeface="Meiryo" pitchFamily="34" charset="-120"/>
-              </a:rPr>
-              <a:t>約6割</a:t>
-            </a:r>
-            <a:endParaRPr lang="en-US" sz="2800" dirty="0"/>
+              <a:rPr lang="en-US" sz="1050" dirty="0">
+                <a:solidFill>
+                  <a:srgbClr val="D9DCE1"/>
+                </a:solidFill>
+                <a:latin typeface="Meiryo" pitchFamily="34" charset="0"/>
+                <a:ea typeface="Meiryo" pitchFamily="34" charset="-122"/>
+                <a:cs typeface="Meiryo" pitchFamily="34" charset="-120"/>
+              </a:rPr>
+              <a:t>転倒災害のうち休業見込みが1か月以上。「ただ転んだだけ」では済まない</a:t>
+            </a:r>
+            <a:endParaRPr lang="en-US" sz="1050" dirty="0"/>
           </a:p>
         </p:txBody>
       </p:sp>
@@ -1275,8 +1275,8 @@
         </p:nvSpPr>
         <p:spPr>
           <a:xfrm>
-            <a:off x="731520" y="3767328"/>
-            <a:ext cx="2743200" cy="731520"/>
+            <a:off x="731520" y="4572000"/>
+            <a:ext cx="2743200" cy="548640"/>
           </a:xfrm>
           <a:prstGeom prst="rect">
             <a:avLst/>
@@ -1292,17 +1292,17 @@
               <a:buNone/>
             </a:pPr>
             <a:r>
-              <a:rPr lang="en-US" sz="1050" dirty="0">
-                <a:solidFill>
-                  <a:srgbClr val="D9DCE1"/>
-                </a:solidFill>
-                <a:latin typeface="Meiryo" pitchFamily="34" charset="0"/>
-                <a:ea typeface="Meiryo" pitchFamily="34" charset="-122"/>
-                <a:cs typeface="Meiryo" pitchFamily="34" charset="-120"/>
-              </a:rPr>
-              <a:t>転倒災害のうち休業見込みが1か月以上。「ただ転んだだけ」では済まない</a:t>
-            </a:r>
-            <a:endParaRPr lang="en-US" sz="1050" dirty="0"/>
+              <a:rPr lang="en-US" sz="2800" b="1" dirty="0">
+                <a:solidFill>
+                  <a:srgbClr val="FFC20E"/>
+                </a:solidFill>
+                <a:latin typeface="Meiryo" pitchFamily="34" charset="0"/>
+                <a:ea typeface="Meiryo" pitchFamily="34" charset="-122"/>
+                <a:cs typeface="Meiryo" pitchFamily="34" charset="-120"/>
+              </a:rPr>
+              <a:t>過半数</a:t>
+            </a:r>
+            <a:endParaRPr lang="en-US" sz="2800" dirty="0"/>
           </a:p>
         </p:txBody>
       </p:sp>
@@ -1314,8 +1314,8 @@
         </p:nvSpPr>
         <p:spPr>
           <a:xfrm>
-            <a:off x="731520" y="4572000"/>
-            <a:ext cx="2743200" cy="548640"/>
+            <a:off x="731520" y="5138928"/>
+            <a:ext cx="2743200" cy="731520"/>
           </a:xfrm>
           <a:prstGeom prst="rect">
             <a:avLst/>
@@ -1331,17 +1331,17 @@
               <a:buNone/>
             </a:pPr>
             <a:r>
-              <a:rPr lang="en-US" sz="2800" b="1" dirty="0">
-                <a:solidFill>
-                  <a:srgbClr val="FFC20E"/>
-                </a:solidFill>
-                <a:latin typeface="Meiryo" pitchFamily="34" charset="0"/>
-                <a:ea typeface="Meiryo" pitchFamily="34" charset="-122"/>
-                <a:cs typeface="Meiryo" pitchFamily="34" charset="-120"/>
-              </a:rPr>
-              <a:t>過半数</a:t>
-            </a:r>
-            <a:endParaRPr lang="en-US" sz="2800" dirty="0"/>
+              <a:rPr lang="en-US" sz="1050" dirty="0">
+                <a:solidFill>
+                  <a:srgbClr val="D9DCE1"/>
+                </a:solidFill>
+                <a:latin typeface="Meiryo" pitchFamily="34" charset="0"/>
+                <a:ea typeface="Meiryo" pitchFamily="34" charset="-122"/>
+                <a:cs typeface="Meiryo" pitchFamily="34" charset="-120"/>
+              </a:rPr>
+              <a:t>被災者のうち50歳以上が占める割合。経験豊富なベテランほど要注意</a:t>
+            </a:r>
+            <a:endParaRPr lang="en-US" sz="1050" dirty="0"/>
           </a:p>
         </p:txBody>
       </p:sp>
@@ -1353,45 +1353,6 @@
         </p:nvSpPr>
         <p:spPr>
           <a:xfrm>
-            <a:off x="731520" y="5138928"/>
-            <a:ext cx="2743200" cy="731520"/>
-          </a:xfrm>
-          <a:prstGeom prst="rect">
-            <a:avLst/>
-          </a:prstGeom>
-          <a:noFill/>
-          <a:ln/>
-        </p:spPr>
-        <p:txBody>
-          <a:bodyPr wrap="square" lIns="0" tIns="0" rIns="0" bIns="0" rtlCol="0" anchor="t"/>
-          <a:lstStyle/>
-          <a:p>
-            <a:pPr indent="0" marL="0">
-              <a:buNone/>
-            </a:pPr>
-            <a:r>
-              <a:rPr lang="en-US" sz="1050" dirty="0">
-                <a:solidFill>
-                  <a:srgbClr val="D9DCE1"/>
-                </a:solidFill>
-                <a:latin typeface="Meiryo" pitchFamily="34" charset="0"/>
-                <a:ea typeface="Meiryo" pitchFamily="34" charset="-122"/>
-                <a:cs typeface="Meiryo" pitchFamily="34" charset="-120"/>
-              </a:rPr>
-              <a:t>被災者のうち50歳以上が占める割合。経験豊富なベテランほど要注意</a:t>
-            </a:r>
-            <a:endParaRPr lang="en-US" sz="1050" dirty="0"/>
-          </a:p>
-        </p:txBody>
-      </p:sp>
-      <p:sp>
-        <p:nvSpPr>
-          <p:cNvPr id="14" name="Text 11"/>
-          <p:cNvSpPr txBox="1"/>
-          <p:nvPr/>
-        </p:nvSpPr>
-        <p:spPr>
-          <a:xfrm>
             <a:off x="731520" y="5897880"/>
             <a:ext cx="2743200" cy="274320"/>
           </a:xfrm>
@@ -1425,7 +1386,7 @@
       </p:sp>
       <p:sp>
         <p:nvSpPr>
-          <p:cNvPr id="15" name="Shape 12"/>
+          <p:cNvPr id="14" name="Shape 11"/>
           <p:cNvSpPr/>
           <p:nvPr/>
         </p:nvSpPr>
@@ -1447,7 +1408,7 @@
       </p:sp>
       <p:sp>
         <p:nvSpPr>
-          <p:cNvPr id="16" name="Shape 13"/>
+          <p:cNvPr id="15" name="Shape 12"/>
           <p:cNvSpPr/>
           <p:nvPr/>
         </p:nvSpPr>
@@ -1467,14 +1428,53 @@
       </p:sp>
       <p:sp>
         <p:nvSpPr>
+          <p:cNvPr id="16" name="Text 13"/>
+          <p:cNvSpPr txBox="1"/>
+          <p:nvPr/>
+        </p:nvSpPr>
+        <p:spPr>
+          <a:xfrm>
+            <a:off x="4206240" y="1261872"/>
+            <a:ext cx="384048" cy="384048"/>
+          </a:xfrm>
+          <a:prstGeom prst="rect">
+            <a:avLst/>
+          </a:prstGeom>
+          <a:noFill/>
+          <a:ln/>
+        </p:spPr>
+        <p:txBody>
+          <a:bodyPr wrap="square" lIns="0" tIns="0" rIns="0" bIns="0" rtlCol="0" anchor="ctr"/>
+          <a:lstStyle/>
+          <a:p>
+            <a:pPr algn="ctr" indent="0" marL="0">
+              <a:buNone/>
+            </a:pPr>
+            <a:r>
+              <a:rPr lang="en-US" sz="1400" b="1" dirty="0">
+                <a:solidFill>
+                  <a:srgbClr val="FFFFFF"/>
+                </a:solidFill>
+                <a:latin typeface="Meiryo" pitchFamily="34" charset="0"/>
+                <a:ea typeface="Meiryo" pitchFamily="34" charset="-122"/>
+                <a:cs typeface="Meiryo" pitchFamily="34" charset="-120"/>
+              </a:rPr>
+              <a:t>1</a:t>
+            </a:r>
+            <a:endParaRPr lang="en-US" sz="1400" dirty="0"/>
+          </a:p>
+        </p:txBody>
+      </p:sp>
+      <p:sp>
+        <p:nvSpPr>
           <p:cNvPr id="17" name="Text 14"/>
           <p:cNvSpPr txBox="1"/>
           <p:nvPr/>
         </p:nvSpPr>
         <p:spPr>
           <a:xfrm>
-            <a:off x="4206240" y="1261872"/>
-            <a:ext cx="384048" cy="384048"/>
+            <a:off x="4709160" y="1261872"/>
+            <a:ext cx="2871216" cy="384048"/>
           </a:xfrm>
           <a:prstGeom prst="rect">
             <a:avLst/>
@@ -1486,19 +1486,19 @@
           <a:bodyPr wrap="square" lIns="0" tIns="0" rIns="0" bIns="0" rtlCol="0" anchor="ctr"/>
           <a:lstStyle/>
           <a:p>
-            <a:pPr algn="ctr" indent="0" marL="0">
+            <a:pPr indent="0" marL="0">
               <a:buNone/>
             </a:pPr>
             <a:r>
               <a:rPr lang="en-US" sz="1400" b="1" dirty="0">
                 <a:solidFill>
-                  <a:srgbClr val="FFFFFF"/>
-                </a:solidFill>
-                <a:latin typeface="Meiryo" pitchFamily="34" charset="0"/>
-                <a:ea typeface="Meiryo" pitchFamily="34" charset="-122"/>
-                <a:cs typeface="Meiryo" pitchFamily="34" charset="-120"/>
-              </a:rPr>
-              <a:t>1</a:t>
+                  <a:srgbClr val="262A30"/>
+                </a:solidFill>
+                <a:latin typeface="Meiryo" pitchFamily="34" charset="0"/>
+                <a:ea typeface="Meiryo" pitchFamily="34" charset="-122"/>
+                <a:cs typeface="Meiryo" pitchFamily="34" charset="-120"/>
+              </a:rPr>
+              <a:t>通路のケーブルにつまずき</a:t>
             </a:r>
             <a:endParaRPr lang="en-US" sz="1400" dirty="0"/>
           </a:p>
@@ -1512,45 +1512,6 @@
         </p:nvSpPr>
         <p:spPr>
           <a:xfrm>
-            <a:off x="4709160" y="1261872"/>
-            <a:ext cx="2871216" cy="384048"/>
-          </a:xfrm>
-          <a:prstGeom prst="rect">
-            <a:avLst/>
-          </a:prstGeom>
-          <a:noFill/>
-          <a:ln/>
-        </p:spPr>
-        <p:txBody>
-          <a:bodyPr wrap="square" lIns="0" tIns="0" rIns="0" bIns="0" rtlCol="0" anchor="ctr"/>
-          <a:lstStyle/>
-          <a:p>
-            <a:pPr indent="0" marL="0">
-              <a:buNone/>
-            </a:pPr>
-            <a:r>
-              <a:rPr lang="en-US" sz="1400" b="1" dirty="0">
-                <a:solidFill>
-                  <a:srgbClr val="262A30"/>
-                </a:solidFill>
-                <a:latin typeface="Meiryo" pitchFamily="34" charset="0"/>
-                <a:ea typeface="Meiryo" pitchFamily="34" charset="-122"/>
-                <a:cs typeface="Meiryo" pitchFamily="34" charset="-120"/>
-              </a:rPr>
-              <a:t>通路のケーブルにつまずき</a:t>
-            </a:r>
-            <a:endParaRPr lang="en-US" sz="1400" dirty="0"/>
-          </a:p>
-        </p:txBody>
-      </p:sp>
-      <p:sp>
-        <p:nvSpPr>
-          <p:cNvPr id="19" name="Text 16"/>
-          <p:cNvSpPr txBox="1"/>
-          <p:nvPr/>
-        </p:nvSpPr>
-        <p:spPr>
-          <a:xfrm>
             <a:off x="4206240" y="1755648"/>
             <a:ext cx="3374136" cy="1234440"/>
           </a:xfrm>
@@ -1715,7 +1676,7 @@
       </p:sp>
       <p:sp>
         <p:nvSpPr>
-          <p:cNvPr id="20" name="Shape 17"/>
+          <p:cNvPr id="19" name="Shape 16"/>
           <p:cNvSpPr/>
           <p:nvPr/>
         </p:nvSpPr>
@@ -1737,7 +1698,7 @@
       </p:sp>
       <p:sp>
         <p:nvSpPr>
-          <p:cNvPr id="21" name="Shape 18"/>
+          <p:cNvPr id="20" name="Shape 17"/>
           <p:cNvSpPr/>
           <p:nvPr/>
         </p:nvSpPr>
@@ -1757,14 +1718,53 @@
       </p:sp>
       <p:sp>
         <p:nvSpPr>
+          <p:cNvPr id="21" name="Text 18"/>
+          <p:cNvSpPr txBox="1"/>
+          <p:nvPr/>
+        </p:nvSpPr>
+        <p:spPr>
+          <a:xfrm>
+            <a:off x="8174736" y="1261872"/>
+            <a:ext cx="384048" cy="384048"/>
+          </a:xfrm>
+          <a:prstGeom prst="rect">
+            <a:avLst/>
+          </a:prstGeom>
+          <a:noFill/>
+          <a:ln/>
+        </p:spPr>
+        <p:txBody>
+          <a:bodyPr wrap="square" lIns="0" tIns="0" rIns="0" bIns="0" rtlCol="0" anchor="ctr"/>
+          <a:lstStyle/>
+          <a:p>
+            <a:pPr algn="ctr" indent="0" marL="0">
+              <a:buNone/>
+            </a:pPr>
+            <a:r>
+              <a:rPr lang="en-US" sz="1400" b="1" dirty="0">
+                <a:solidFill>
+                  <a:srgbClr val="FFFFFF"/>
+                </a:solidFill>
+                <a:latin typeface="Meiryo" pitchFamily="34" charset="0"/>
+                <a:ea typeface="Meiryo" pitchFamily="34" charset="-122"/>
+                <a:cs typeface="Meiryo" pitchFamily="34" charset="-120"/>
+              </a:rPr>
+              <a:t>2</a:t>
+            </a:r>
+            <a:endParaRPr lang="en-US" sz="1400" dirty="0"/>
+          </a:p>
+        </p:txBody>
+      </p:sp>
+      <p:sp>
+        <p:nvSpPr>
           <p:cNvPr id="22" name="Text 19"/>
           <p:cNvSpPr txBox="1"/>
           <p:nvPr/>
         </p:nvSpPr>
         <p:spPr>
           <a:xfrm>
-            <a:off x="8174736" y="1261872"/>
-            <a:ext cx="384048" cy="384048"/>
+            <a:off x="8677656" y="1261872"/>
+            <a:ext cx="2871216" cy="384048"/>
           </a:xfrm>
           <a:prstGeom prst="rect">
             <a:avLst/>
@@ -1776,19 +1776,19 @@
           <a:bodyPr wrap="square" lIns="0" tIns="0" rIns="0" bIns="0" rtlCol="0" anchor="ctr"/>
           <a:lstStyle/>
           <a:p>
-            <a:pPr algn="ctr" indent="0" marL="0">
+            <a:pPr indent="0" marL="0">
               <a:buNone/>
             </a:pPr>
             <a:r>
               <a:rPr lang="en-US" sz="1400" b="1" dirty="0">
                 <a:solidFill>
-                  <a:srgbClr val="FFFFFF"/>
-                </a:solidFill>
-                <a:latin typeface="Meiryo" pitchFamily="34" charset="0"/>
-                <a:ea typeface="Meiryo" pitchFamily="34" charset="-122"/>
-                <a:cs typeface="Meiryo" pitchFamily="34" charset="-120"/>
-              </a:rPr>
-              <a:t>2</a:t>
+                  <a:srgbClr val="262A30"/>
+                </a:solidFill>
+                <a:latin typeface="Meiryo" pitchFamily="34" charset="0"/>
+                <a:ea typeface="Meiryo" pitchFamily="34" charset="-122"/>
+                <a:cs typeface="Meiryo" pitchFamily="34" charset="-120"/>
+              </a:rPr>
+              <a:t>雨上がりの敷鉄板で滑る</a:t>
             </a:r>
             <a:endParaRPr lang="en-US" sz="1400" dirty="0"/>
           </a:p>
@@ -1802,45 +1802,6 @@
         </p:nvSpPr>
         <p:spPr>
           <a:xfrm>
-            <a:off x="8677656" y="1261872"/>
-            <a:ext cx="2871216" cy="384048"/>
-          </a:xfrm>
-          <a:prstGeom prst="rect">
-            <a:avLst/>
-          </a:prstGeom>
-          <a:noFill/>
-          <a:ln/>
-        </p:spPr>
-        <p:txBody>
-          <a:bodyPr wrap="square" lIns="0" tIns="0" rIns="0" bIns="0" rtlCol="0" anchor="ctr"/>
-          <a:lstStyle/>
-          <a:p>
-            <a:pPr indent="0" marL="0">
-              <a:buNone/>
-            </a:pPr>
-            <a:r>
-              <a:rPr lang="en-US" sz="1400" b="1" dirty="0">
-                <a:solidFill>
-                  <a:srgbClr val="262A30"/>
-                </a:solidFill>
-                <a:latin typeface="Meiryo" pitchFamily="34" charset="0"/>
-                <a:ea typeface="Meiryo" pitchFamily="34" charset="-122"/>
-                <a:cs typeface="Meiryo" pitchFamily="34" charset="-120"/>
-              </a:rPr>
-              <a:t>雨上がりの敷鉄板で滑る</a:t>
-            </a:r>
-            <a:endParaRPr lang="en-US" sz="1400" dirty="0"/>
-          </a:p>
-        </p:txBody>
-      </p:sp>
-      <p:sp>
-        <p:nvSpPr>
-          <p:cNvPr id="24" name="Text 21"/>
-          <p:cNvSpPr txBox="1"/>
-          <p:nvPr/>
-        </p:nvSpPr>
-        <p:spPr>
-          <a:xfrm>
             <a:off x="8174736" y="1755648"/>
             <a:ext cx="3374136" cy="1234440"/>
           </a:xfrm>
@@ -2005,7 +1966,7 @@
       </p:sp>
       <p:sp>
         <p:nvSpPr>
-          <p:cNvPr id="25" name="Shape 22"/>
+          <p:cNvPr id="24" name="Shape 21"/>
           <p:cNvSpPr/>
           <p:nvPr/>
         </p:nvSpPr>
@@ -2027,7 +1988,7 @@
       </p:sp>
       <p:sp>
         <p:nvSpPr>
-          <p:cNvPr id="26" name="Shape 23"/>
+          <p:cNvPr id="25" name="Shape 22"/>
           <p:cNvSpPr/>
           <p:nvPr/>
         </p:nvSpPr>
@@ -2047,14 +2008,53 @@
       </p:sp>
       <p:sp>
         <p:nvSpPr>
+          <p:cNvPr id="26" name="Text 23"/>
+          <p:cNvSpPr txBox="1"/>
+          <p:nvPr/>
+        </p:nvSpPr>
+        <p:spPr>
+          <a:xfrm>
+            <a:off x="4206240" y="3502152"/>
+            <a:ext cx="384048" cy="384048"/>
+          </a:xfrm>
+          <a:prstGeom prst="rect">
+            <a:avLst/>
+          </a:prstGeom>
+          <a:noFill/>
+          <a:ln/>
+        </p:spPr>
+        <p:txBody>
+          <a:bodyPr wrap="square" lIns="0" tIns="0" rIns="0" bIns="0" rtlCol="0" anchor="ctr"/>
+          <a:lstStyle/>
+          <a:p>
+            <a:pPr algn="ctr" indent="0" marL="0">
+              <a:buNone/>
+            </a:pPr>
+            <a:r>
+              <a:rPr lang="en-US" sz="1400" b="1" dirty="0">
+                <a:solidFill>
+                  <a:srgbClr val="FFFFFF"/>
+                </a:solidFill>
+                <a:latin typeface="Meiryo" pitchFamily="34" charset="0"/>
+                <a:ea typeface="Meiryo" pitchFamily="34" charset="-122"/>
+                <a:cs typeface="Meiryo" pitchFamily="34" charset="-120"/>
+              </a:rPr>
+              <a:t>3</a:t>
+            </a:r>
+            <a:endParaRPr lang="en-US" sz="1400" dirty="0"/>
+          </a:p>
+        </p:txBody>
+      </p:sp>
+      <p:sp>
+        <p:nvSpPr>
           <p:cNvPr id="27" name="Text 24"/>
           <p:cNvSpPr txBox="1"/>
           <p:nvPr/>
         </p:nvSpPr>
         <p:spPr>
           <a:xfrm>
-            <a:off x="4206240" y="3502152"/>
-            <a:ext cx="384048" cy="384048"/>
+            <a:off x="4709160" y="3502152"/>
+            <a:ext cx="2871216" cy="384048"/>
           </a:xfrm>
           <a:prstGeom prst="rect">
             <a:avLst/>
@@ -2066,19 +2066,19 @@
           <a:bodyPr wrap="square" lIns="0" tIns="0" rIns="0" bIns="0" rtlCol="0" anchor="ctr"/>
           <a:lstStyle/>
           <a:p>
-            <a:pPr algn="ctr" indent="0" marL="0">
+            <a:pPr indent="0" marL="0">
               <a:buNone/>
             </a:pPr>
             <a:r>
               <a:rPr lang="en-US" sz="1400" b="1" dirty="0">
                 <a:solidFill>
-                  <a:srgbClr val="FFFFFF"/>
-                </a:solidFill>
-                <a:latin typeface="Meiryo" pitchFamily="34" charset="0"/>
-                <a:ea typeface="Meiryo" pitchFamily="34" charset="-122"/>
-                <a:cs typeface="Meiryo" pitchFamily="34" charset="-120"/>
-              </a:rPr>
-              <a:t>3</a:t>
+                  <a:srgbClr val="262A30"/>
+                </a:solidFill>
+                <a:latin typeface="Meiryo" pitchFamily="34" charset="0"/>
+                <a:ea typeface="Meiryo" pitchFamily="34" charset="-122"/>
+                <a:cs typeface="Meiryo" pitchFamily="34" charset="-120"/>
+              </a:rPr>
+              <a:t>床養生の段差につまずき</a:t>
             </a:r>
             <a:endParaRPr lang="en-US" sz="1400" dirty="0"/>
           </a:p>
@@ -2092,45 +2092,6 @@
         </p:nvSpPr>
         <p:spPr>
           <a:xfrm>
-            <a:off x="4709160" y="3502152"/>
-            <a:ext cx="2871216" cy="384048"/>
-          </a:xfrm>
-          <a:prstGeom prst="rect">
-            <a:avLst/>
-          </a:prstGeom>
-          <a:noFill/>
-          <a:ln/>
-        </p:spPr>
-        <p:txBody>
-          <a:bodyPr wrap="square" lIns="0" tIns="0" rIns="0" bIns="0" rtlCol="0" anchor="ctr"/>
-          <a:lstStyle/>
-          <a:p>
-            <a:pPr indent="0" marL="0">
-              <a:buNone/>
-            </a:pPr>
-            <a:r>
-              <a:rPr lang="en-US" sz="1400" b="1" dirty="0">
-                <a:solidFill>
-                  <a:srgbClr val="262A30"/>
-                </a:solidFill>
-                <a:latin typeface="Meiryo" pitchFamily="34" charset="0"/>
-                <a:ea typeface="Meiryo" pitchFamily="34" charset="-122"/>
-                <a:cs typeface="Meiryo" pitchFamily="34" charset="-120"/>
-              </a:rPr>
-              <a:t>床養生の段差につまずき</a:t>
-            </a:r>
-            <a:endParaRPr lang="en-US" sz="1400" dirty="0"/>
-          </a:p>
-        </p:txBody>
-      </p:sp>
-      <p:sp>
-        <p:nvSpPr>
-          <p:cNvPr id="29" name="Text 26"/>
-          <p:cNvSpPr txBox="1"/>
-          <p:nvPr/>
-        </p:nvSpPr>
-        <p:spPr>
-          <a:xfrm>
             <a:off x="4206240" y="3995928"/>
             <a:ext cx="3374136" cy="1234440"/>
           </a:xfrm>
@@ -2295,7 +2256,7 @@
       </p:sp>
       <p:sp>
         <p:nvSpPr>
-          <p:cNvPr id="30" name="Shape 27"/>
+          <p:cNvPr id="29" name="Shape 26"/>
           <p:cNvSpPr/>
           <p:nvPr/>
         </p:nvSpPr>
@@ -2317,7 +2278,7 @@
       </p:sp>
       <p:sp>
         <p:nvSpPr>
-          <p:cNvPr id="31" name="Shape 28"/>
+          <p:cNvPr id="30" name="Shape 27"/>
           <p:cNvSpPr/>
           <p:nvPr/>
         </p:nvSpPr>
@@ -2337,14 +2298,53 @@
       </p:sp>
       <p:sp>
         <p:nvSpPr>
+          <p:cNvPr id="31" name="Text 28"/>
+          <p:cNvSpPr txBox="1"/>
+          <p:nvPr/>
+        </p:nvSpPr>
+        <p:spPr>
+          <a:xfrm>
+            <a:off x="8174736" y="3502152"/>
+            <a:ext cx="384048" cy="384048"/>
+          </a:xfrm>
+          <a:prstGeom prst="rect">
+            <a:avLst/>
+          </a:prstGeom>
+          <a:noFill/>
+          <a:ln/>
+        </p:spPr>
+        <p:txBody>
+          <a:bodyPr wrap="square" lIns="0" tIns="0" rIns="0" bIns="0" rtlCol="0" anchor="ctr"/>
+          <a:lstStyle/>
+          <a:p>
+            <a:pPr algn="ctr" indent="0" marL="0">
+              <a:buNone/>
+            </a:pPr>
+            <a:r>
+              <a:rPr lang="en-US" sz="1400" b="1" dirty="0">
+                <a:solidFill>
+                  <a:srgbClr val="FFFFFF"/>
+                </a:solidFill>
+                <a:latin typeface="Meiryo" pitchFamily="34" charset="0"/>
+                <a:ea typeface="Meiryo" pitchFamily="34" charset="-122"/>
+                <a:cs typeface="Meiryo" pitchFamily="34" charset="-120"/>
+              </a:rPr>
+              <a:t>4</a:t>
+            </a:r>
+            <a:endParaRPr lang="en-US" sz="1400" dirty="0"/>
+          </a:p>
+        </p:txBody>
+      </p:sp>
+      <p:sp>
+        <p:nvSpPr>
           <p:cNvPr id="32" name="Text 29"/>
           <p:cNvSpPr txBox="1"/>
           <p:nvPr/>
         </p:nvSpPr>
         <p:spPr>
           <a:xfrm>
-            <a:off x="8174736" y="3502152"/>
-            <a:ext cx="384048" cy="384048"/>
+            <a:off x="8677656" y="3502152"/>
+            <a:ext cx="2871216" cy="384048"/>
           </a:xfrm>
           <a:prstGeom prst="rect">
             <a:avLst/>
@@ -2356,19 +2356,19 @@
           <a:bodyPr wrap="square" lIns="0" tIns="0" rIns="0" bIns="0" rtlCol="0" anchor="ctr"/>
           <a:lstStyle/>
           <a:p>
-            <a:pPr algn="ctr" indent="0" marL="0">
+            <a:pPr indent="0" marL="0">
               <a:buNone/>
             </a:pPr>
             <a:r>
               <a:rPr lang="en-US" sz="1400" b="1" dirty="0">
                 <a:solidFill>
-                  <a:srgbClr val="FFFFFF"/>
-                </a:solidFill>
-                <a:latin typeface="Meiryo" pitchFamily="34" charset="0"/>
-                <a:ea typeface="Meiryo" pitchFamily="34" charset="-122"/>
-                <a:cs typeface="Meiryo" pitchFamily="34" charset="-120"/>
-              </a:rPr>
-              <a:t>4</a:t>
+                  <a:srgbClr val="262A30"/>
+                </a:solidFill>
+                <a:latin typeface="Meiryo" pitchFamily="34" charset="0"/>
+                <a:ea typeface="Meiryo" pitchFamily="34" charset="-122"/>
+                <a:cs typeface="Meiryo" pitchFamily="34" charset="-120"/>
+              </a:rPr>
+              <a:t>資材を抱えて階段を踏み外し</a:t>
             </a:r>
             <a:endParaRPr lang="en-US" sz="1400" dirty="0"/>
           </a:p>
@@ -2382,8 +2382,8 @@
         </p:nvSpPr>
         <p:spPr>
           <a:xfrm>
-            <a:off x="8677656" y="3502152"/>
-            <a:ext cx="2871216" cy="384048"/>
+            <a:off x="8174736" y="3995928"/>
+            <a:ext cx="3374136" cy="1234440"/>
           </a:xfrm>
           <a:prstGeom prst="rect">
             <a:avLst/>
@@ -2392,24 +2392,155 @@
           <a:ln/>
         </p:spPr>
         <p:txBody>
-          <a:bodyPr wrap="square" lIns="0" tIns="0" rIns="0" bIns="0" rtlCol="0" anchor="ctr"/>
-          <a:lstStyle/>
-          <a:p>
-            <a:pPr indent="0" marL="0">
-              <a:buNone/>
-            </a:pPr>
-            <a:r>
-              <a:rPr lang="en-US" sz="1400" b="1" dirty="0">
-                <a:solidFill>
-                  <a:srgbClr val="262A30"/>
-                </a:solidFill>
-                <a:latin typeface="Meiryo" pitchFamily="34" charset="0"/>
-                <a:ea typeface="Meiryo" pitchFamily="34" charset="-122"/>
-                <a:cs typeface="Meiryo" pitchFamily="34" charset="-120"/>
-              </a:rPr>
-              <a:t>資材を抱えて階段を踏み外し</a:t>
-            </a:r>
-            <a:endParaRPr lang="en-US" sz="1400" dirty="0"/>
+          <a:bodyPr wrap="square" lIns="0" tIns="0" rIns="0" bIns="0" rtlCol="0" anchor="t"/>
+          <a:lstStyle/>
+          <a:p>
+            <a:pPr indent="0" marL="0">
+              <a:spcAft>
+                <a:spcPts val="300"/>
+              </a:spcAft>
+              <a:buNone/>
+            </a:pPr>
+            <a:r>
+              <a:rPr lang="en-US" sz="1100" b="1" dirty="0">
+                <a:solidFill>
+                  <a:srgbClr val="5B616B"/>
+                </a:solidFill>
+                <a:latin typeface="Meiryo" pitchFamily="34" charset="0"/>
+                <a:ea typeface="Meiryo" pitchFamily="34" charset="-122"/>
+                <a:cs typeface="Meiryo" pitchFamily="34" charset="-120"/>
+              </a:rPr>
+              <a:t>状況　</a:t>
+            </a:r>
+            <a:pPr indent="0" marL="0">
+              <a:spcAft>
+                <a:spcPts val="300"/>
+              </a:spcAft>
+              <a:buNone/>
+            </a:pPr>
+            <a:r>
+              <a:rPr lang="en-US" sz="1100" dirty="0">
+                <a:solidFill>
+                  <a:srgbClr val="262A30"/>
+                </a:solidFill>
+                <a:latin typeface="Meiryo" pitchFamily="34" charset="0"/>
+                <a:ea typeface="Meiryo" pitchFamily="34" charset="-122"/>
+                <a:cs typeface="Meiryo" pitchFamily="34" charset="-120"/>
+              </a:rPr>
+              <a:t>両手で資材を抱えて仮設階段を下りる際、足元が見えず最後の一段を踏み外した</a:t>
+            </a:r>
+            <a:endParaRPr lang="en-US" sz="1100" dirty="0"/>
+          </a:p>
+          <a:p>
+            <a:pPr indent="0" marL="0">
+              <a:spcAft>
+                <a:spcPts val="300"/>
+              </a:spcAft>
+              <a:buNone/>
+            </a:pPr>
+            <a:r>
+              <a:rPr lang="en-US" sz="1100" b="1" dirty="0">
+                <a:solidFill>
+                  <a:srgbClr val="D7263D"/>
+                </a:solidFill>
+                <a:latin typeface="Meiryo" pitchFamily="34" charset="0"/>
+                <a:ea typeface="Meiryo" pitchFamily="34" charset="-122"/>
+                <a:cs typeface="Meiryo" pitchFamily="34" charset="-120"/>
+              </a:rPr>
+              <a:t>原因　</a:t>
+            </a:r>
+            <a:pPr indent="0" marL="0">
+              <a:spcAft>
+                <a:spcPts val="300"/>
+              </a:spcAft>
+              <a:buNone/>
+            </a:pPr>
+            <a:r>
+              <a:rPr lang="en-US" sz="1100" dirty="0">
+                <a:solidFill>
+                  <a:srgbClr val="262A30"/>
+                </a:solidFill>
+                <a:latin typeface="Meiryo" pitchFamily="34" charset="0"/>
+                <a:ea typeface="Meiryo" pitchFamily="34" charset="-122"/>
+                <a:cs typeface="Meiryo" pitchFamily="34" charset="-120"/>
+              </a:rPr>
+              <a:t>手すりを持てない運搬。階段の照明不足</a:t>
+            </a:r>
+            <a:endParaRPr lang="en-US" sz="1100" dirty="0"/>
+          </a:p>
+          <a:p>
+            <a:pPr indent="0" marL="0">
+              <a:spcAft>
+                <a:spcPts val="300"/>
+              </a:spcAft>
+              <a:buNone/>
+            </a:pPr>
+            <a:r>
+              <a:rPr lang="en-US" sz="1100" b="1" dirty="0">
+                <a:solidFill>
+                  <a:srgbClr val="5B616B"/>
+                </a:solidFill>
+                <a:latin typeface="Meiryo" pitchFamily="34" charset="0"/>
+                <a:ea typeface="Meiryo" pitchFamily="34" charset="-122"/>
+                <a:cs typeface="Meiryo" pitchFamily="34" charset="-120"/>
+              </a:rPr>
+              <a:t>被害　</a:t>
+            </a:r>
+            <a:pPr indent="0" marL="0">
+              <a:spcAft>
+                <a:spcPts val="300"/>
+              </a:spcAft>
+              <a:buNone/>
+            </a:pPr>
+            <a:r>
+              <a:rPr lang="en-US" sz="1100" dirty="0">
+                <a:solidFill>
+                  <a:srgbClr val="262A30"/>
+                </a:solidFill>
+                <a:latin typeface="Meiryo" pitchFamily="34" charset="0"/>
+                <a:ea typeface="Meiryo" pitchFamily="34" charset="-122"/>
+                <a:cs typeface="Meiryo" pitchFamily="34" charset="-120"/>
+              </a:rPr>
+              <a:t>左足首捻挫・靱帯損傷</a:t>
+            </a:r>
+            <a:endParaRPr lang="en-US" sz="1100" dirty="0"/>
+          </a:p>
+          <a:p>
+            <a:pPr indent="0" marL="0">
+              <a:spcAft>
+                <a:spcPts val="300"/>
+              </a:spcAft>
+              <a:buNone/>
+            </a:pPr>
+            <a:r>
+              <a:rPr lang="en-US" sz="1100" b="1" dirty="0">
+                <a:solidFill>
+                  <a:srgbClr val="1F7A3A"/>
+                </a:solidFill>
+                <a:latin typeface="Meiryo" pitchFamily="34" charset="0"/>
+                <a:ea typeface="Meiryo" pitchFamily="34" charset="-122"/>
+                <a:cs typeface="Meiryo" pitchFamily="34" charset="-120"/>
+              </a:rPr>
+              <a:t>対策　</a:t>
+            </a:r>
+            <a:pPr indent="0" marL="0">
+              <a:spcAft>
+                <a:spcPts val="300"/>
+              </a:spcAft>
+              <a:buNone/>
+            </a:pPr>
+            <a:r>
+              <a:rPr lang="en-US" sz="1100" dirty="0">
+                <a:solidFill>
+                  <a:srgbClr val="262A30"/>
+                </a:solidFill>
+                <a:latin typeface="Meiryo" pitchFamily="34" charset="0"/>
+                <a:ea typeface="Meiryo" pitchFamily="34" charset="-122"/>
+                <a:cs typeface="Meiryo" pitchFamily="34" charset="-120"/>
+              </a:rPr>
+              <a:t>片手を空けて運搬、階段に照明を増設</a:t>
+            </a:r>
+            <a:endParaRPr lang="en-US" sz="1100" dirty="0"/>
           </a:p>
         </p:txBody>
       </p:sp>
@@ -2421,176 +2552,6 @@
         </p:nvSpPr>
         <p:spPr>
           <a:xfrm>
-            <a:off x="8174736" y="3995928"/>
-            <a:ext cx="3374136" cy="1234440"/>
-          </a:xfrm>
-          <a:prstGeom prst="rect">
-            <a:avLst/>
-          </a:prstGeom>
-          <a:noFill/>
-          <a:ln/>
-        </p:spPr>
-        <p:txBody>
-          <a:bodyPr wrap="square" lIns="0" tIns="0" rIns="0" bIns="0" rtlCol="0" anchor="t"/>
-          <a:lstStyle/>
-          <a:p>
-            <a:pPr indent="0" marL="0">
-              <a:spcAft>
-                <a:spcPts val="300"/>
-              </a:spcAft>
-              <a:buNone/>
-            </a:pPr>
-            <a:r>
-              <a:rPr lang="en-US" sz="1100" b="1" dirty="0">
-                <a:solidFill>
-                  <a:srgbClr val="5B616B"/>
-                </a:solidFill>
-                <a:latin typeface="Meiryo" pitchFamily="34" charset="0"/>
-                <a:ea typeface="Meiryo" pitchFamily="34" charset="-122"/>
-                <a:cs typeface="Meiryo" pitchFamily="34" charset="-120"/>
-              </a:rPr>
-              <a:t>状況　</a:t>
-            </a:r>
-            <a:pPr indent="0" marL="0">
-              <a:spcAft>
-                <a:spcPts val="300"/>
-              </a:spcAft>
-              <a:buNone/>
-            </a:pPr>
-            <a:r>
-              <a:rPr lang="en-US" sz="1100" dirty="0">
-                <a:solidFill>
-                  <a:srgbClr val="262A30"/>
-                </a:solidFill>
-                <a:latin typeface="Meiryo" pitchFamily="34" charset="0"/>
-                <a:ea typeface="Meiryo" pitchFamily="34" charset="-122"/>
-                <a:cs typeface="Meiryo" pitchFamily="34" charset="-120"/>
-              </a:rPr>
-              <a:t>両手で資材を抱えて仮設階段を下りる際、足元が見えず最後の一段を踏み外した</a:t>
-            </a:r>
-            <a:endParaRPr lang="en-US" sz="1100" dirty="0"/>
-          </a:p>
-          <a:p>
-            <a:pPr indent="0" marL="0">
-              <a:spcAft>
-                <a:spcPts val="300"/>
-              </a:spcAft>
-              <a:buNone/>
-            </a:pPr>
-            <a:r>
-              <a:rPr lang="en-US" sz="1100" b="1" dirty="0">
-                <a:solidFill>
-                  <a:srgbClr val="D7263D"/>
-                </a:solidFill>
-                <a:latin typeface="Meiryo" pitchFamily="34" charset="0"/>
-                <a:ea typeface="Meiryo" pitchFamily="34" charset="-122"/>
-                <a:cs typeface="Meiryo" pitchFamily="34" charset="-120"/>
-              </a:rPr>
-              <a:t>原因　</a:t>
-            </a:r>
-            <a:pPr indent="0" marL="0">
-              <a:spcAft>
-                <a:spcPts val="300"/>
-              </a:spcAft>
-              <a:buNone/>
-            </a:pPr>
-            <a:r>
-              <a:rPr lang="en-US" sz="1100" dirty="0">
-                <a:solidFill>
-                  <a:srgbClr val="262A30"/>
-                </a:solidFill>
-                <a:latin typeface="Meiryo" pitchFamily="34" charset="0"/>
-                <a:ea typeface="Meiryo" pitchFamily="34" charset="-122"/>
-                <a:cs typeface="Meiryo" pitchFamily="34" charset="-120"/>
-              </a:rPr>
-              <a:t>手すりを持てない運搬。階段の照明不足</a:t>
-            </a:r>
-            <a:endParaRPr lang="en-US" sz="1100" dirty="0"/>
-          </a:p>
-          <a:p>
-            <a:pPr indent="0" marL="0">
-              <a:spcAft>
-                <a:spcPts val="300"/>
-              </a:spcAft>
-              <a:buNone/>
-            </a:pPr>
-            <a:r>
-              <a:rPr lang="en-US" sz="1100" b="1" dirty="0">
-                <a:solidFill>
-                  <a:srgbClr val="5B616B"/>
-                </a:solidFill>
-                <a:latin typeface="Meiryo" pitchFamily="34" charset="0"/>
-                <a:ea typeface="Meiryo" pitchFamily="34" charset="-122"/>
-                <a:cs typeface="Meiryo" pitchFamily="34" charset="-120"/>
-              </a:rPr>
-              <a:t>被害　</a:t>
-            </a:r>
-            <a:pPr indent="0" marL="0">
-              <a:spcAft>
-                <a:spcPts val="300"/>
-              </a:spcAft>
-              <a:buNone/>
-            </a:pPr>
-            <a:r>
-              <a:rPr lang="en-US" sz="1100" dirty="0">
-                <a:solidFill>
-                  <a:srgbClr val="262A30"/>
-                </a:solidFill>
-                <a:latin typeface="Meiryo" pitchFamily="34" charset="0"/>
-                <a:ea typeface="Meiryo" pitchFamily="34" charset="-122"/>
-                <a:cs typeface="Meiryo" pitchFamily="34" charset="-120"/>
-              </a:rPr>
-              <a:t>左足首捻挫・靱帯損傷</a:t>
-            </a:r>
-            <a:endParaRPr lang="en-US" sz="1100" dirty="0"/>
-          </a:p>
-          <a:p>
-            <a:pPr indent="0" marL="0">
-              <a:spcAft>
-                <a:spcPts val="300"/>
-              </a:spcAft>
-              <a:buNone/>
-            </a:pPr>
-            <a:r>
-              <a:rPr lang="en-US" sz="1100" b="1" dirty="0">
-                <a:solidFill>
-                  <a:srgbClr val="1F7A3A"/>
-                </a:solidFill>
-                <a:latin typeface="Meiryo" pitchFamily="34" charset="0"/>
-                <a:ea typeface="Meiryo" pitchFamily="34" charset="-122"/>
-                <a:cs typeface="Meiryo" pitchFamily="34" charset="-120"/>
-              </a:rPr>
-              <a:t>対策　</a:t>
-            </a:r>
-            <a:pPr indent="0" marL="0">
-              <a:spcAft>
-                <a:spcPts val="300"/>
-              </a:spcAft>
-              <a:buNone/>
-            </a:pPr>
-            <a:r>
-              <a:rPr lang="en-US" sz="1100" dirty="0">
-                <a:solidFill>
-                  <a:srgbClr val="262A30"/>
-                </a:solidFill>
-                <a:latin typeface="Meiryo" pitchFamily="34" charset="0"/>
-                <a:ea typeface="Meiryo" pitchFamily="34" charset="-122"/>
-                <a:cs typeface="Meiryo" pitchFamily="34" charset="-120"/>
-              </a:rPr>
-              <a:t>片手を空けて運搬、階段に照明を増設</a:t>
-            </a:r>
-            <a:endParaRPr lang="en-US" sz="1100" dirty="0"/>
-          </a:p>
-        </p:txBody>
-      </p:sp>
-      <p:sp>
-        <p:nvSpPr>
-          <p:cNvPr id="35" name="Text 32"/>
-          <p:cNvSpPr txBox="1"/>
-          <p:nvPr/>
-        </p:nvSpPr>
-        <p:spPr>
-          <a:xfrm>
             <a:off x="4023360" y="5623560"/>
             <a:ext cx="914400" cy="685800"/>
           </a:xfrm>
@@ -2641,7 +2602,7 @@
       </p:sp>
       <p:sp>
         <p:nvSpPr>
-          <p:cNvPr id="36" name="Shape 33"/>
+          <p:cNvPr id="35" name="Shape 32"/>
           <p:cNvSpPr/>
           <p:nvPr/>
         </p:nvSpPr>
@@ -2663,7 +2624,7 @@
       </p:sp>
       <p:sp>
         <p:nvSpPr>
-          <p:cNvPr id="37" name="Text 34"/>
+          <p:cNvPr id="36" name="Text 33"/>
           <p:cNvSpPr txBox="1"/>
           <p:nvPr/>
         </p:nvSpPr>
@@ -2702,7 +2663,7 @@
       </p:sp>
       <p:sp>
         <p:nvSpPr>
-          <p:cNvPr id="38" name="Shape 35"/>
+          <p:cNvPr id="37" name="Shape 34"/>
           <p:cNvSpPr/>
           <p:nvPr/>
         </p:nvSpPr>
@@ -2724,7 +2685,7 @@
       </p:sp>
       <p:sp>
         <p:nvSpPr>
-          <p:cNvPr id="39" name="Text 36"/>
+          <p:cNvPr id="38" name="Text 35"/>
           <p:cNvSpPr txBox="1"/>
           <p:nvPr/>
         </p:nvSpPr>
@@ -2763,7 +2724,7 @@
       </p:sp>
       <p:sp>
         <p:nvSpPr>
-          <p:cNvPr id="40" name="Shape 37"/>
+          <p:cNvPr id="39" name="Shape 36"/>
           <p:cNvSpPr/>
           <p:nvPr/>
         </p:nvSpPr>
@@ -2785,7 +2746,7 @@
       </p:sp>
       <p:sp>
         <p:nvSpPr>
-          <p:cNvPr id="41" name="Text 38"/>
+          <p:cNvPr id="40" name="Text 37"/>
           <p:cNvSpPr txBox="1"/>
           <p:nvPr/>
         </p:nvSpPr>
@@ -2824,7 +2785,7 @@
       </p:sp>
       <p:sp>
         <p:nvSpPr>
-          <p:cNvPr id="42" name="Shape 39"/>
+          <p:cNvPr id="41" name="Shape 38"/>
           <p:cNvSpPr/>
           <p:nvPr/>
         </p:nvSpPr>
@@ -2846,7 +2807,7 @@
       </p:sp>
       <p:sp>
         <p:nvSpPr>
-          <p:cNvPr id="43" name="Text 40"/>
+          <p:cNvPr id="42" name="Text 39"/>
           <p:cNvSpPr txBox="1"/>
           <p:nvPr/>
         </p:nvSpPr>
@@ -2885,7 +2846,7 @@
       </p:sp>
       <p:sp>
         <p:nvSpPr>
-          <p:cNvPr id="44" name="Shape 41"/>
+          <p:cNvPr id="43" name="Shape 40"/>
           <p:cNvSpPr/>
           <p:nvPr/>
         </p:nvSpPr>
@@ -2907,7 +2868,7 @@
       </p:sp>
       <p:sp>
         <p:nvSpPr>
-          <p:cNvPr id="45" name="Text 42"/>
+          <p:cNvPr id="44" name="Text 41"/>
           <p:cNvSpPr txBox="1"/>
           <p:nvPr/>
         </p:nvSpPr>
@@ -3061,46 +3022,7 @@
       </p:sp>
       <p:sp>
         <p:nvSpPr>
-          <p:cNvPr id="5" name="Text 2"/>
-          <p:cNvSpPr txBox="1"/>
-          <p:nvPr/>
-        </p:nvSpPr>
-        <p:spPr>
-          <a:xfrm>
-            <a:off x="9052560" y="256032"/>
-            <a:ext cx="2679192" cy="603504"/>
-          </a:xfrm>
-          <a:prstGeom prst="rect">
-            <a:avLst/>
-          </a:prstGeom>
-          <a:noFill/>
-          <a:ln/>
-        </p:spPr>
-        <p:txBody>
-          <a:bodyPr wrap="square" lIns="0" tIns="0" rIns="0" bIns="0" rtlCol="0" anchor="ctr"/>
-          <a:lstStyle/>
-          <a:p>
-            <a:pPr algn="r" indent="0" marL="0">
-              <a:buNone/>
-            </a:pPr>
-            <a:r>
-              <a:rPr lang="en-US" sz="1100" dirty="0">
-                <a:solidFill>
-                  <a:srgbClr val="5B616B"/>
-                </a:solidFill>
-                <a:latin typeface="Meiryo" pitchFamily="34" charset="0"/>
-                <a:ea typeface="Meiryo" pitchFamily="34" charset="-122"/>
-                <a:cs typeface="Meiryo" pitchFamily="34" charset="-120"/>
-              </a:rPr>
-              <a:t>安全衛生協議会 ｜ 建築工事</a:t>
-            </a:r>
-            <a:endParaRPr lang="en-US" sz="1100" dirty="0"/>
-          </a:p>
-        </p:txBody>
-      </p:sp>
-      <p:sp>
-        <p:nvSpPr>
-          <p:cNvPr id="6" name="Shape 3"/>
+          <p:cNvPr id="5" name="Shape 2"/>
           <p:cNvSpPr/>
           <p:nvPr/>
         </p:nvSpPr>
@@ -3122,7 +3044,7 @@
       </p:sp>
       <p:sp>
         <p:nvSpPr>
-          <p:cNvPr id="7" name="Shape 4"/>
+          <p:cNvPr id="6" name="Shape 3"/>
           <p:cNvSpPr/>
           <p:nvPr/>
         </p:nvSpPr>
@@ -3142,7 +3064,7 @@
       </p:sp>
       <p:pic>
         <p:nvPicPr>
-          <p:cNvPr id="8" name="Image 1" descr="preencoded.png">    </p:cNvPr>
+          <p:cNvPr id="7" name="Image 1" descr="preencoded.png">    </p:cNvPr>
           <p:cNvPicPr>
             <a:picLocks noChangeAspect="1"/>
           </p:cNvPicPr>
@@ -3166,51 +3088,51 @@
       </p:pic>
       <p:sp>
         <p:nvSpPr>
+          <p:cNvPr id="8" name="Text 4"/>
+          <p:cNvSpPr txBox="1"/>
+          <p:nvPr/>
+        </p:nvSpPr>
+        <p:spPr>
+          <a:xfrm>
+            <a:off x="1207008" y="1280160"/>
+            <a:ext cx="1732788" cy="457200"/>
+          </a:xfrm>
+          <a:prstGeom prst="rect">
+            <a:avLst/>
+          </a:prstGeom>
+          <a:noFill/>
+          <a:ln/>
+        </p:spPr>
+        <p:txBody>
+          <a:bodyPr wrap="square" lIns="0" tIns="0" rIns="0" bIns="0" rtlCol="0" anchor="ctr"/>
+          <a:lstStyle/>
+          <a:p>
+            <a:pPr indent="0" marL="0">
+              <a:buNone/>
+            </a:pPr>
+            <a:r>
+              <a:rPr lang="en-US" sz="1400" b="1" dirty="0">
+                <a:solidFill>
+                  <a:srgbClr val="262A30"/>
+                </a:solidFill>
+                <a:latin typeface="Meiryo" pitchFamily="34" charset="0"/>
+                <a:ea typeface="Meiryo" pitchFamily="34" charset="-122"/>
+                <a:cs typeface="Meiryo" pitchFamily="34" charset="-120"/>
+              </a:rPr>
+              <a:t>通路を確保する</a:t>
+            </a:r>
+            <a:endParaRPr lang="en-US" sz="1400" dirty="0"/>
+          </a:p>
+        </p:txBody>
+      </p:sp>
+      <p:sp>
+        <p:nvSpPr>
           <p:cNvPr id="9" name="Text 5"/>
           <p:cNvSpPr txBox="1"/>
           <p:nvPr/>
         </p:nvSpPr>
         <p:spPr>
           <a:xfrm>
-            <a:off x="1207008" y="1280160"/>
-            <a:ext cx="1732788" cy="457200"/>
-          </a:xfrm>
-          <a:prstGeom prst="rect">
-            <a:avLst/>
-          </a:prstGeom>
-          <a:noFill/>
-          <a:ln/>
-        </p:spPr>
-        <p:txBody>
-          <a:bodyPr wrap="square" lIns="0" tIns="0" rIns="0" bIns="0" rtlCol="0" anchor="ctr"/>
-          <a:lstStyle/>
-          <a:p>
-            <a:pPr indent="0" marL="0">
-              <a:buNone/>
-            </a:pPr>
-            <a:r>
-              <a:rPr lang="en-US" sz="1400" b="1" dirty="0">
-                <a:solidFill>
-                  <a:srgbClr val="262A30"/>
-                </a:solidFill>
-                <a:latin typeface="Meiryo" pitchFamily="34" charset="0"/>
-                <a:ea typeface="Meiryo" pitchFamily="34" charset="-122"/>
-                <a:cs typeface="Meiryo" pitchFamily="34" charset="-120"/>
-              </a:rPr>
-              <a:t>通路を確保する</a:t>
-            </a:r>
-            <a:endParaRPr lang="en-US" sz="1400" dirty="0"/>
-          </a:p>
-        </p:txBody>
-      </p:sp>
-      <p:sp>
-        <p:nvSpPr>
-          <p:cNvPr id="10" name="Text 6"/>
-          <p:cNvSpPr txBox="1"/>
-          <p:nvPr/>
-        </p:nvSpPr>
-        <p:spPr>
-          <a:xfrm>
             <a:off x="640080" y="1874520"/>
             <a:ext cx="2372868" cy="1188720"/>
           </a:xfrm>
@@ -3311,7 +3233,7 @@
       </p:sp>
       <p:sp>
         <p:nvSpPr>
-          <p:cNvPr id="11" name="Shape 7"/>
+          <p:cNvPr id="10" name="Shape 6"/>
           <p:cNvSpPr/>
           <p:nvPr/>
         </p:nvSpPr>
@@ -3333,7 +3255,7 @@
       </p:sp>
       <p:sp>
         <p:nvSpPr>
-          <p:cNvPr id="12" name="Shape 8"/>
+          <p:cNvPr id="11" name="Shape 7"/>
           <p:cNvSpPr/>
           <p:nvPr/>
         </p:nvSpPr>
@@ -3353,7 +3275,7 @@
       </p:sp>
       <p:pic>
         <p:nvPicPr>
-          <p:cNvPr id="13" name="Image 2" descr="preencoded.png">    </p:cNvPr>
+          <p:cNvPr id="12" name="Image 2" descr="preencoded.png">    </p:cNvPr>
           <p:cNvPicPr>
             <a:picLocks noChangeAspect="1"/>
           </p:cNvPicPr>
@@ -3377,51 +3299,51 @@
       </p:pic>
       <p:sp>
         <p:nvSpPr>
+          <p:cNvPr id="13" name="Text 8"/>
+          <p:cNvSpPr txBox="1"/>
+          <p:nvPr/>
+        </p:nvSpPr>
+        <p:spPr>
+          <a:xfrm>
+            <a:off x="4082796" y="1280160"/>
+            <a:ext cx="1732788" cy="457200"/>
+          </a:xfrm>
+          <a:prstGeom prst="rect">
+            <a:avLst/>
+          </a:prstGeom>
+          <a:noFill/>
+          <a:ln/>
+        </p:spPr>
+        <p:txBody>
+          <a:bodyPr wrap="square" lIns="0" tIns="0" rIns="0" bIns="0" rtlCol="0" anchor="ctr"/>
+          <a:lstStyle/>
+          <a:p>
+            <a:pPr indent="0" marL="0">
+              <a:buNone/>
+            </a:pPr>
+            <a:r>
+              <a:rPr lang="en-US" sz="1400" b="1" dirty="0">
+                <a:solidFill>
+                  <a:srgbClr val="262A30"/>
+                </a:solidFill>
+                <a:latin typeface="Meiryo" pitchFamily="34" charset="0"/>
+                <a:ea typeface="Meiryo" pitchFamily="34" charset="-122"/>
+                <a:cs typeface="Meiryo" pitchFamily="34" charset="-120"/>
+              </a:rPr>
+              <a:t>配線・ホースを整理</a:t>
+            </a:r>
+            <a:endParaRPr lang="en-US" sz="1400" dirty="0"/>
+          </a:p>
+        </p:txBody>
+      </p:sp>
+      <p:sp>
+        <p:nvSpPr>
           <p:cNvPr id="14" name="Text 9"/>
           <p:cNvSpPr txBox="1"/>
           <p:nvPr/>
         </p:nvSpPr>
         <p:spPr>
           <a:xfrm>
-            <a:off x="4082796" y="1280160"/>
-            <a:ext cx="1732788" cy="457200"/>
-          </a:xfrm>
-          <a:prstGeom prst="rect">
-            <a:avLst/>
-          </a:prstGeom>
-          <a:noFill/>
-          <a:ln/>
-        </p:spPr>
-        <p:txBody>
-          <a:bodyPr wrap="square" lIns="0" tIns="0" rIns="0" bIns="0" rtlCol="0" anchor="ctr"/>
-          <a:lstStyle/>
-          <a:p>
-            <a:pPr indent="0" marL="0">
-              <a:buNone/>
-            </a:pPr>
-            <a:r>
-              <a:rPr lang="en-US" sz="1400" b="1" dirty="0">
-                <a:solidFill>
-                  <a:srgbClr val="262A30"/>
-                </a:solidFill>
-                <a:latin typeface="Meiryo" pitchFamily="34" charset="0"/>
-                <a:ea typeface="Meiryo" pitchFamily="34" charset="-122"/>
-                <a:cs typeface="Meiryo" pitchFamily="34" charset="-120"/>
-              </a:rPr>
-              <a:t>配線・ホースを整理</a:t>
-            </a:r>
-            <a:endParaRPr lang="en-US" sz="1400" dirty="0"/>
-          </a:p>
-        </p:txBody>
-      </p:sp>
-      <p:sp>
-        <p:nvSpPr>
-          <p:cNvPr id="15" name="Text 10"/>
-          <p:cNvSpPr txBox="1"/>
-          <p:nvPr/>
-        </p:nvSpPr>
-        <p:spPr>
-          <a:xfrm>
             <a:off x="3515868" y="1874520"/>
             <a:ext cx="2372868" cy="1188720"/>
           </a:xfrm>
@@ -3522,7 +3444,7 @@
       </p:sp>
       <p:sp>
         <p:nvSpPr>
-          <p:cNvPr id="16" name="Shape 11"/>
+          <p:cNvPr id="15" name="Shape 10"/>
           <p:cNvSpPr/>
           <p:nvPr/>
         </p:nvSpPr>
@@ -3544,7 +3466,7 @@
       </p:sp>
       <p:sp>
         <p:nvSpPr>
-          <p:cNvPr id="17" name="Shape 12"/>
+          <p:cNvPr id="16" name="Shape 11"/>
           <p:cNvSpPr/>
           <p:nvPr/>
         </p:nvSpPr>
@@ -3564,7 +3486,7 @@
       </p:sp>
       <p:pic>
         <p:nvPicPr>
-          <p:cNvPr id="18" name="Image 3" descr="preencoded.png">    </p:cNvPr>
+          <p:cNvPr id="17" name="Image 3" descr="preencoded.png">    </p:cNvPr>
           <p:cNvPicPr>
             <a:picLocks noChangeAspect="1"/>
           </p:cNvPicPr>
@@ -3588,51 +3510,51 @@
       </p:pic>
       <p:sp>
         <p:nvSpPr>
+          <p:cNvPr id="18" name="Text 12"/>
+          <p:cNvSpPr txBox="1"/>
+          <p:nvPr/>
+        </p:nvSpPr>
+        <p:spPr>
+          <a:xfrm>
+            <a:off x="6958584" y="1280160"/>
+            <a:ext cx="1732788" cy="457200"/>
+          </a:xfrm>
+          <a:prstGeom prst="rect">
+            <a:avLst/>
+          </a:prstGeom>
+          <a:noFill/>
+          <a:ln/>
+        </p:spPr>
+        <p:txBody>
+          <a:bodyPr wrap="square" lIns="0" tIns="0" rIns="0" bIns="0" rtlCol="0" anchor="ctr"/>
+          <a:lstStyle/>
+          <a:p>
+            <a:pPr indent="0" marL="0">
+              <a:buNone/>
+            </a:pPr>
+            <a:r>
+              <a:rPr lang="en-US" sz="1400" b="1" dirty="0">
+                <a:solidFill>
+                  <a:srgbClr val="262A30"/>
+                </a:solidFill>
+                <a:latin typeface="Meiryo" pitchFamily="34" charset="0"/>
+                <a:ea typeface="Meiryo" pitchFamily="34" charset="-122"/>
+                <a:cs typeface="Meiryo" pitchFamily="34" charset="-120"/>
+              </a:rPr>
+              <a:t>段差・開口を養生</a:t>
+            </a:r>
+            <a:endParaRPr lang="en-US" sz="1400" dirty="0"/>
+          </a:p>
+        </p:txBody>
+      </p:sp>
+      <p:sp>
+        <p:nvSpPr>
           <p:cNvPr id="19" name="Text 13"/>
           <p:cNvSpPr txBox="1"/>
           <p:nvPr/>
         </p:nvSpPr>
         <p:spPr>
           <a:xfrm>
-            <a:off x="6958584" y="1280160"/>
-            <a:ext cx="1732788" cy="457200"/>
-          </a:xfrm>
-          <a:prstGeom prst="rect">
-            <a:avLst/>
-          </a:prstGeom>
-          <a:noFill/>
-          <a:ln/>
-        </p:spPr>
-        <p:txBody>
-          <a:bodyPr wrap="square" lIns="0" tIns="0" rIns="0" bIns="0" rtlCol="0" anchor="ctr"/>
-          <a:lstStyle/>
-          <a:p>
-            <a:pPr indent="0" marL="0">
-              <a:buNone/>
-            </a:pPr>
-            <a:r>
-              <a:rPr lang="en-US" sz="1400" b="1" dirty="0">
-                <a:solidFill>
-                  <a:srgbClr val="262A30"/>
-                </a:solidFill>
-                <a:latin typeface="Meiryo" pitchFamily="34" charset="0"/>
-                <a:ea typeface="Meiryo" pitchFamily="34" charset="-122"/>
-                <a:cs typeface="Meiryo" pitchFamily="34" charset="-120"/>
-              </a:rPr>
-              <a:t>段差・開口を養生</a:t>
-            </a:r>
-            <a:endParaRPr lang="en-US" sz="1400" dirty="0"/>
-          </a:p>
-        </p:txBody>
-      </p:sp>
-      <p:sp>
-        <p:nvSpPr>
-          <p:cNvPr id="20" name="Text 14"/>
-          <p:cNvSpPr txBox="1"/>
-          <p:nvPr/>
-        </p:nvSpPr>
-        <p:spPr>
-          <a:xfrm>
             <a:off x="6391656" y="1874520"/>
             <a:ext cx="2372868" cy="1188720"/>
           </a:xfrm>
@@ -3733,7 +3655,7 @@
       </p:sp>
       <p:sp>
         <p:nvSpPr>
-          <p:cNvPr id="21" name="Shape 15"/>
+          <p:cNvPr id="20" name="Shape 14"/>
           <p:cNvSpPr/>
           <p:nvPr/>
         </p:nvSpPr>
@@ -3755,7 +3677,7 @@
       </p:sp>
       <p:sp>
         <p:nvSpPr>
-          <p:cNvPr id="22" name="Shape 16"/>
+          <p:cNvPr id="21" name="Shape 15"/>
           <p:cNvSpPr/>
           <p:nvPr/>
         </p:nvSpPr>
@@ -3775,7 +3697,7 @@
       </p:sp>
       <p:pic>
         <p:nvPicPr>
-          <p:cNvPr id="23" name="Image 4" descr="preencoded.png">    </p:cNvPr>
+          <p:cNvPr id="22" name="Image 4" descr="preencoded.png">    </p:cNvPr>
           <p:cNvPicPr>
             <a:picLocks noChangeAspect="1"/>
           </p:cNvPicPr>
@@ -3799,51 +3721,51 @@
       </p:pic>
       <p:sp>
         <p:nvSpPr>
+          <p:cNvPr id="23" name="Text 16"/>
+          <p:cNvSpPr txBox="1"/>
+          <p:nvPr/>
+        </p:nvSpPr>
+        <p:spPr>
+          <a:xfrm>
+            <a:off x="9834372" y="1280160"/>
+            <a:ext cx="1732788" cy="457200"/>
+          </a:xfrm>
+          <a:prstGeom prst="rect">
+            <a:avLst/>
+          </a:prstGeom>
+          <a:noFill/>
+          <a:ln/>
+        </p:spPr>
+        <p:txBody>
+          <a:bodyPr wrap="square" lIns="0" tIns="0" rIns="0" bIns="0" rtlCol="0" anchor="ctr"/>
+          <a:lstStyle/>
+          <a:p>
+            <a:pPr indent="0" marL="0">
+              <a:buNone/>
+            </a:pPr>
+            <a:r>
+              <a:rPr lang="en-US" sz="1400" b="1" dirty="0">
+                <a:solidFill>
+                  <a:srgbClr val="262A30"/>
+                </a:solidFill>
+                <a:latin typeface="Meiryo" pitchFamily="34" charset="0"/>
+                <a:ea typeface="Meiryo" pitchFamily="34" charset="-122"/>
+                <a:cs typeface="Meiryo" pitchFamily="34" charset="-120"/>
+              </a:rPr>
+              <a:t>滑りを防ぐ</a:t>
+            </a:r>
+            <a:endParaRPr lang="en-US" sz="1400" dirty="0"/>
+          </a:p>
+        </p:txBody>
+      </p:sp>
+      <p:sp>
+        <p:nvSpPr>
           <p:cNvPr id="24" name="Text 17"/>
           <p:cNvSpPr txBox="1"/>
           <p:nvPr/>
         </p:nvSpPr>
         <p:spPr>
           <a:xfrm>
-            <a:off x="9834372" y="1280160"/>
-            <a:ext cx="1732788" cy="457200"/>
-          </a:xfrm>
-          <a:prstGeom prst="rect">
-            <a:avLst/>
-          </a:prstGeom>
-          <a:noFill/>
-          <a:ln/>
-        </p:spPr>
-        <p:txBody>
-          <a:bodyPr wrap="square" lIns="0" tIns="0" rIns="0" bIns="0" rtlCol="0" anchor="ctr"/>
-          <a:lstStyle/>
-          <a:p>
-            <a:pPr indent="0" marL="0">
-              <a:buNone/>
-            </a:pPr>
-            <a:r>
-              <a:rPr lang="en-US" sz="1400" b="1" dirty="0">
-                <a:solidFill>
-                  <a:srgbClr val="262A30"/>
-                </a:solidFill>
-                <a:latin typeface="Meiryo" pitchFamily="34" charset="0"/>
-                <a:ea typeface="Meiryo" pitchFamily="34" charset="-122"/>
-                <a:cs typeface="Meiryo" pitchFamily="34" charset="-120"/>
-              </a:rPr>
-              <a:t>滑りを防ぐ</a:t>
-            </a:r>
-            <a:endParaRPr lang="en-US" sz="1400" dirty="0"/>
-          </a:p>
-        </p:txBody>
-      </p:sp>
-      <p:sp>
-        <p:nvSpPr>
-          <p:cNvPr id="25" name="Text 18"/>
-          <p:cNvSpPr txBox="1"/>
-          <p:nvPr/>
-        </p:nvSpPr>
-        <p:spPr>
-          <a:xfrm>
             <a:off x="9267444" y="1874520"/>
             <a:ext cx="2372868" cy="1188720"/>
           </a:xfrm>
@@ -3944,7 +3866,7 @@
       </p:sp>
       <p:sp>
         <p:nvSpPr>
-          <p:cNvPr id="26" name="Shape 19"/>
+          <p:cNvPr id="25" name="Shape 18"/>
           <p:cNvSpPr/>
           <p:nvPr/>
         </p:nvSpPr>
@@ -3966,7 +3888,7 @@
       </p:sp>
       <p:sp>
         <p:nvSpPr>
-          <p:cNvPr id="27" name="Shape 20"/>
+          <p:cNvPr id="26" name="Shape 19"/>
           <p:cNvSpPr/>
           <p:nvPr/>
         </p:nvSpPr>
@@ -3986,7 +3908,7 @@
       </p:sp>
       <p:pic>
         <p:nvPicPr>
-          <p:cNvPr id="28" name="Image 5" descr="preencoded.png">    </p:cNvPr>
+          <p:cNvPr id="27" name="Image 5" descr="preencoded.png">    </p:cNvPr>
           <p:cNvPicPr>
             <a:picLocks noChangeAspect="1"/>
           </p:cNvPicPr>
@@ -4010,51 +3932,51 @@
       </p:pic>
       <p:sp>
         <p:nvSpPr>
+          <p:cNvPr id="28" name="Text 20"/>
+          <p:cNvSpPr txBox="1"/>
+          <p:nvPr/>
+        </p:nvSpPr>
+        <p:spPr>
+          <a:xfrm>
+            <a:off x="1207008" y="3566160"/>
+            <a:ext cx="1732788" cy="457200"/>
+          </a:xfrm>
+          <a:prstGeom prst="rect">
+            <a:avLst/>
+          </a:prstGeom>
+          <a:noFill/>
+          <a:ln/>
+        </p:spPr>
+        <p:txBody>
+          <a:bodyPr wrap="square" lIns="0" tIns="0" rIns="0" bIns="0" rtlCol="0" anchor="ctr"/>
+          <a:lstStyle/>
+          <a:p>
+            <a:pPr indent="0" marL="0">
+              <a:buNone/>
+            </a:pPr>
+            <a:r>
+              <a:rPr lang="en-US" sz="1400" b="1" dirty="0">
+                <a:solidFill>
+                  <a:srgbClr val="262A30"/>
+                </a:solidFill>
+                <a:latin typeface="Meiryo" pitchFamily="34" charset="0"/>
+                <a:ea typeface="Meiryo" pitchFamily="34" charset="-122"/>
+                <a:cs typeface="Meiryo" pitchFamily="34" charset="-120"/>
+              </a:rPr>
+              <a:t>明るさを確保</a:t>
+            </a:r>
+            <a:endParaRPr lang="en-US" sz="1400" dirty="0"/>
+          </a:p>
+        </p:txBody>
+      </p:sp>
+      <p:sp>
+        <p:nvSpPr>
           <p:cNvPr id="29" name="Text 21"/>
           <p:cNvSpPr txBox="1"/>
           <p:nvPr/>
         </p:nvSpPr>
         <p:spPr>
           <a:xfrm>
-            <a:off x="1207008" y="3566160"/>
-            <a:ext cx="1732788" cy="457200"/>
-          </a:xfrm>
-          <a:prstGeom prst="rect">
-            <a:avLst/>
-          </a:prstGeom>
-          <a:noFill/>
-          <a:ln/>
-        </p:spPr>
-        <p:txBody>
-          <a:bodyPr wrap="square" lIns="0" tIns="0" rIns="0" bIns="0" rtlCol="0" anchor="ctr"/>
-          <a:lstStyle/>
-          <a:p>
-            <a:pPr indent="0" marL="0">
-              <a:buNone/>
-            </a:pPr>
-            <a:r>
-              <a:rPr lang="en-US" sz="1400" b="1" dirty="0">
-                <a:solidFill>
-                  <a:srgbClr val="262A30"/>
-                </a:solidFill>
-                <a:latin typeface="Meiryo" pitchFamily="34" charset="0"/>
-                <a:ea typeface="Meiryo" pitchFamily="34" charset="-122"/>
-                <a:cs typeface="Meiryo" pitchFamily="34" charset="-120"/>
-              </a:rPr>
-              <a:t>明るさを確保</a:t>
-            </a:r>
-            <a:endParaRPr lang="en-US" sz="1400" dirty="0"/>
-          </a:p>
-        </p:txBody>
-      </p:sp>
-      <p:sp>
-        <p:nvSpPr>
-          <p:cNvPr id="30" name="Text 22"/>
-          <p:cNvSpPr txBox="1"/>
-          <p:nvPr/>
-        </p:nvSpPr>
-        <p:spPr>
-          <a:xfrm>
             <a:off x="640080" y="4160520"/>
             <a:ext cx="2372868" cy="1188720"/>
           </a:xfrm>
@@ -4155,7 +4077,7 @@
       </p:sp>
       <p:sp>
         <p:nvSpPr>
-          <p:cNvPr id="31" name="Shape 23"/>
+          <p:cNvPr id="30" name="Shape 22"/>
           <p:cNvSpPr/>
           <p:nvPr/>
         </p:nvSpPr>
@@ -4177,7 +4099,7 @@
       </p:sp>
       <p:sp>
         <p:nvSpPr>
-          <p:cNvPr id="32" name="Shape 24"/>
+          <p:cNvPr id="31" name="Shape 23"/>
           <p:cNvSpPr/>
           <p:nvPr/>
         </p:nvSpPr>
@@ -4197,7 +4119,7 @@
       </p:sp>
       <p:pic>
         <p:nvPicPr>
-          <p:cNvPr id="33" name="Image 6" descr="preencoded.png">    </p:cNvPr>
+          <p:cNvPr id="32" name="Image 6" descr="preencoded.png">    </p:cNvPr>
           <p:cNvPicPr>
             <a:picLocks noChangeAspect="1"/>
           </p:cNvPicPr>
@@ -4221,51 +4143,51 @@
       </p:pic>
       <p:sp>
         <p:nvSpPr>
+          <p:cNvPr id="33" name="Text 24"/>
+          <p:cNvSpPr txBox="1"/>
+          <p:nvPr/>
+        </p:nvSpPr>
+        <p:spPr>
+          <a:xfrm>
+            <a:off x="4082796" y="3566160"/>
+            <a:ext cx="1732788" cy="457200"/>
+          </a:xfrm>
+          <a:prstGeom prst="rect">
+            <a:avLst/>
+          </a:prstGeom>
+          <a:noFill/>
+          <a:ln/>
+        </p:spPr>
+        <p:txBody>
+          <a:bodyPr wrap="square" lIns="0" tIns="0" rIns="0" bIns="0" rtlCol="0" anchor="ctr"/>
+          <a:lstStyle/>
+          <a:p>
+            <a:pPr indent="0" marL="0">
+              <a:buNone/>
+            </a:pPr>
+            <a:r>
+              <a:rPr lang="en-US" sz="1400" b="1" dirty="0">
+                <a:solidFill>
+                  <a:srgbClr val="262A30"/>
+                </a:solidFill>
+                <a:latin typeface="Meiryo" pitchFamily="34" charset="0"/>
+                <a:ea typeface="Meiryo" pitchFamily="34" charset="-122"/>
+                <a:cs typeface="Meiryo" pitchFamily="34" charset="-120"/>
+              </a:rPr>
+              <a:t>歩き方のルール</a:t>
+            </a:r>
+            <a:endParaRPr lang="en-US" sz="1400" dirty="0"/>
+          </a:p>
+        </p:txBody>
+      </p:sp>
+      <p:sp>
+        <p:nvSpPr>
           <p:cNvPr id="34" name="Text 25"/>
           <p:cNvSpPr txBox="1"/>
           <p:nvPr/>
         </p:nvSpPr>
         <p:spPr>
           <a:xfrm>
-            <a:off x="4082796" y="3566160"/>
-            <a:ext cx="1732788" cy="457200"/>
-          </a:xfrm>
-          <a:prstGeom prst="rect">
-            <a:avLst/>
-          </a:prstGeom>
-          <a:noFill/>
-          <a:ln/>
-        </p:spPr>
-        <p:txBody>
-          <a:bodyPr wrap="square" lIns="0" tIns="0" rIns="0" bIns="0" rtlCol="0" anchor="ctr"/>
-          <a:lstStyle/>
-          <a:p>
-            <a:pPr indent="0" marL="0">
-              <a:buNone/>
-            </a:pPr>
-            <a:r>
-              <a:rPr lang="en-US" sz="1400" b="1" dirty="0">
-                <a:solidFill>
-                  <a:srgbClr val="262A30"/>
-                </a:solidFill>
-                <a:latin typeface="Meiryo" pitchFamily="34" charset="0"/>
-                <a:ea typeface="Meiryo" pitchFamily="34" charset="-122"/>
-                <a:cs typeface="Meiryo" pitchFamily="34" charset="-120"/>
-              </a:rPr>
-              <a:t>歩き方のルール</a:t>
-            </a:r>
-            <a:endParaRPr lang="en-US" sz="1400" dirty="0"/>
-          </a:p>
-        </p:txBody>
-      </p:sp>
-      <p:sp>
-        <p:nvSpPr>
-          <p:cNvPr id="35" name="Text 26"/>
-          <p:cNvSpPr txBox="1"/>
-          <p:nvPr/>
-        </p:nvSpPr>
-        <p:spPr>
-          <a:xfrm>
             <a:off x="3515868" y="4160520"/>
             <a:ext cx="2372868" cy="1188720"/>
           </a:xfrm>
@@ -4366,7 +4288,7 @@
       </p:sp>
       <p:sp>
         <p:nvSpPr>
-          <p:cNvPr id="36" name="Shape 27"/>
+          <p:cNvPr id="35" name="Shape 26"/>
           <p:cNvSpPr/>
           <p:nvPr/>
         </p:nvSpPr>
@@ -4388,7 +4310,7 @@
       </p:sp>
       <p:sp>
         <p:nvSpPr>
-          <p:cNvPr id="37" name="Shape 28"/>
+          <p:cNvPr id="36" name="Shape 27"/>
           <p:cNvSpPr/>
           <p:nvPr/>
         </p:nvSpPr>
@@ -4408,7 +4330,7 @@
       </p:sp>
       <p:pic>
         <p:nvPicPr>
-          <p:cNvPr id="38" name="Image 7" descr="preencoded.png">    </p:cNvPr>
+          <p:cNvPr id="37" name="Image 7" descr="preencoded.png">    </p:cNvPr>
           <p:cNvPicPr>
             <a:picLocks noChangeAspect="1"/>
           </p:cNvPicPr>
@@ -4432,51 +4354,51 @@
       </p:pic>
       <p:sp>
         <p:nvSpPr>
+          <p:cNvPr id="38" name="Text 28"/>
+          <p:cNvSpPr txBox="1"/>
+          <p:nvPr/>
+        </p:nvSpPr>
+        <p:spPr>
+          <a:xfrm>
+            <a:off x="6958584" y="3566160"/>
+            <a:ext cx="1732788" cy="457200"/>
+          </a:xfrm>
+          <a:prstGeom prst="rect">
+            <a:avLst/>
+          </a:prstGeom>
+          <a:noFill/>
+          <a:ln/>
+        </p:spPr>
+        <p:txBody>
+          <a:bodyPr wrap="square" lIns="0" tIns="0" rIns="0" bIns="0" rtlCol="0" anchor="ctr"/>
+          <a:lstStyle/>
+          <a:p>
+            <a:pPr indent="0" marL="0">
+              <a:buNone/>
+            </a:pPr>
+            <a:r>
+              <a:rPr lang="en-US" sz="1400" b="1" dirty="0">
+                <a:solidFill>
+                  <a:srgbClr val="262A30"/>
+                </a:solidFill>
+                <a:latin typeface="Meiryo" pitchFamily="34" charset="0"/>
+                <a:ea typeface="Meiryo" pitchFamily="34" charset="-122"/>
+                <a:cs typeface="Meiryo" pitchFamily="34" charset="-120"/>
+              </a:rPr>
+              <a:t>履物・服装</a:t>
+            </a:r>
+            <a:endParaRPr lang="en-US" sz="1400" dirty="0"/>
+          </a:p>
+        </p:txBody>
+      </p:sp>
+      <p:sp>
+        <p:nvSpPr>
           <p:cNvPr id="39" name="Text 29"/>
           <p:cNvSpPr txBox="1"/>
           <p:nvPr/>
         </p:nvSpPr>
         <p:spPr>
           <a:xfrm>
-            <a:off x="6958584" y="3566160"/>
-            <a:ext cx="1732788" cy="457200"/>
-          </a:xfrm>
-          <a:prstGeom prst="rect">
-            <a:avLst/>
-          </a:prstGeom>
-          <a:noFill/>
-          <a:ln/>
-        </p:spPr>
-        <p:txBody>
-          <a:bodyPr wrap="square" lIns="0" tIns="0" rIns="0" bIns="0" rtlCol="0" anchor="ctr"/>
-          <a:lstStyle/>
-          <a:p>
-            <a:pPr indent="0" marL="0">
-              <a:buNone/>
-            </a:pPr>
-            <a:r>
-              <a:rPr lang="en-US" sz="1400" b="1" dirty="0">
-                <a:solidFill>
-                  <a:srgbClr val="262A30"/>
-                </a:solidFill>
-                <a:latin typeface="Meiryo" pitchFamily="34" charset="0"/>
-                <a:ea typeface="Meiryo" pitchFamily="34" charset="-122"/>
-                <a:cs typeface="Meiryo" pitchFamily="34" charset="-120"/>
-              </a:rPr>
-              <a:t>履物・服装</a:t>
-            </a:r>
-            <a:endParaRPr lang="en-US" sz="1400" dirty="0"/>
-          </a:p>
-        </p:txBody>
-      </p:sp>
-      <p:sp>
-        <p:nvSpPr>
-          <p:cNvPr id="40" name="Text 30"/>
-          <p:cNvSpPr txBox="1"/>
-          <p:nvPr/>
-        </p:nvSpPr>
-        <p:spPr>
-          <a:xfrm>
             <a:off x="6391656" y="4160520"/>
             <a:ext cx="2372868" cy="1188720"/>
           </a:xfrm>
@@ -4577,7 +4499,7 @@
       </p:sp>
       <p:sp>
         <p:nvSpPr>
-          <p:cNvPr id="41" name="Shape 31"/>
+          <p:cNvPr id="40" name="Shape 30"/>
           <p:cNvSpPr/>
           <p:nvPr/>
         </p:nvSpPr>
@@ -4599,7 +4521,7 @@
       </p:sp>
       <p:sp>
         <p:nvSpPr>
-          <p:cNvPr id="42" name="Shape 32"/>
+          <p:cNvPr id="41" name="Shape 31"/>
           <p:cNvSpPr/>
           <p:nvPr/>
         </p:nvSpPr>
@@ -4619,7 +4541,7 @@
       </p:sp>
       <p:pic>
         <p:nvPicPr>
-          <p:cNvPr id="43" name="Image 8" descr="preencoded.png">    </p:cNvPr>
+          <p:cNvPr id="42" name="Image 8" descr="preencoded.png">    </p:cNvPr>
           <p:cNvPicPr>
             <a:picLocks noChangeAspect="1"/>
           </p:cNvPicPr>
@@ -4643,51 +4565,51 @@
       </p:pic>
       <p:sp>
         <p:nvSpPr>
+          <p:cNvPr id="43" name="Text 32"/>
+          <p:cNvSpPr txBox="1"/>
+          <p:nvPr/>
+        </p:nvSpPr>
+        <p:spPr>
+          <a:xfrm>
+            <a:off x="9834372" y="3566160"/>
+            <a:ext cx="1732788" cy="457200"/>
+          </a:xfrm>
+          <a:prstGeom prst="rect">
+            <a:avLst/>
+          </a:prstGeom>
+          <a:noFill/>
+          <a:ln/>
+        </p:spPr>
+        <p:txBody>
+          <a:bodyPr wrap="square" lIns="0" tIns="0" rIns="0" bIns="0" rtlCol="0" anchor="ctr"/>
+          <a:lstStyle/>
+          <a:p>
+            <a:pPr indent="0" marL="0">
+              <a:buNone/>
+            </a:pPr>
+            <a:r>
+              <a:rPr lang="en-US" sz="1400" b="1" dirty="0">
+                <a:solidFill>
+                  <a:srgbClr val="262A30"/>
+                </a:solidFill>
+                <a:latin typeface="Meiryo" pitchFamily="34" charset="0"/>
+                <a:ea typeface="Meiryo" pitchFamily="34" charset="-122"/>
+                <a:cs typeface="Meiryo" pitchFamily="34" charset="-120"/>
+              </a:rPr>
+              <a:t>こまめに片付け</a:t>
+            </a:r>
+            <a:endParaRPr lang="en-US" sz="1400" dirty="0"/>
+          </a:p>
+        </p:txBody>
+      </p:sp>
+      <p:sp>
+        <p:nvSpPr>
           <p:cNvPr id="44" name="Text 33"/>
           <p:cNvSpPr txBox="1"/>
           <p:nvPr/>
         </p:nvSpPr>
         <p:spPr>
           <a:xfrm>
-            <a:off x="9834372" y="3566160"/>
-            <a:ext cx="1732788" cy="457200"/>
-          </a:xfrm>
-          <a:prstGeom prst="rect">
-            <a:avLst/>
-          </a:prstGeom>
-          <a:noFill/>
-          <a:ln/>
-        </p:spPr>
-        <p:txBody>
-          <a:bodyPr wrap="square" lIns="0" tIns="0" rIns="0" bIns="0" rtlCol="0" anchor="ctr"/>
-          <a:lstStyle/>
-          <a:p>
-            <a:pPr indent="0" marL="0">
-              <a:buNone/>
-            </a:pPr>
-            <a:r>
-              <a:rPr lang="en-US" sz="1400" b="1" dirty="0">
-                <a:solidFill>
-                  <a:srgbClr val="262A30"/>
-                </a:solidFill>
-                <a:latin typeface="Meiryo" pitchFamily="34" charset="0"/>
-                <a:ea typeface="Meiryo" pitchFamily="34" charset="-122"/>
-                <a:cs typeface="Meiryo" pitchFamily="34" charset="-120"/>
-              </a:rPr>
-              <a:t>こまめに片付け</a:t>
-            </a:r>
-            <a:endParaRPr lang="en-US" sz="1400" dirty="0"/>
-          </a:p>
-        </p:txBody>
-      </p:sp>
-      <p:sp>
-        <p:nvSpPr>
-          <p:cNvPr id="45" name="Text 34"/>
-          <p:cNvSpPr txBox="1"/>
-          <p:nvPr/>
-        </p:nvSpPr>
-        <p:spPr>
-          <a:xfrm>
             <a:off x="9267444" y="4160520"/>
             <a:ext cx="2372868" cy="1188720"/>
           </a:xfrm>
@@ -4788,7 +4710,7 @@
       </p:sp>
       <p:sp>
         <p:nvSpPr>
-          <p:cNvPr id="46" name="Shape 35"/>
+          <p:cNvPr id="45" name="Shape 34"/>
           <p:cNvSpPr/>
           <p:nvPr/>
         </p:nvSpPr>
@@ -4810,51 +4732,51 @@
       </p:sp>
       <p:sp>
         <p:nvSpPr>
+          <p:cNvPr id="46" name="Text 35"/>
+          <p:cNvSpPr txBox="1"/>
+          <p:nvPr/>
+        </p:nvSpPr>
+        <p:spPr>
+          <a:xfrm>
+            <a:off x="731520" y="5669280"/>
+            <a:ext cx="822960" cy="777240"/>
+          </a:xfrm>
+          <a:prstGeom prst="rect">
+            <a:avLst/>
+          </a:prstGeom>
+          <a:noFill/>
+          <a:ln/>
+        </p:spPr>
+        <p:txBody>
+          <a:bodyPr wrap="square" lIns="0" tIns="0" rIns="0" bIns="0" rtlCol="0" anchor="ctr"/>
+          <a:lstStyle/>
+          <a:p>
+            <a:pPr indent="0" marL="0">
+              <a:buNone/>
+            </a:pPr>
+            <a:r>
+              <a:rPr lang="en-US" sz="1100" b="1" dirty="0">
+                <a:solidFill>
+                  <a:srgbClr val="B9BEC6"/>
+                </a:solidFill>
+                <a:latin typeface="Meiryo" pitchFamily="34" charset="0"/>
+                <a:ea typeface="Meiryo" pitchFamily="34" charset="-122"/>
+                <a:cs typeface="Meiryo" pitchFamily="34" charset="-120"/>
+              </a:rPr>
+              <a:t>合言葉</a:t>
+            </a:r>
+            <a:endParaRPr lang="en-US" sz="1100" dirty="0"/>
+          </a:p>
+        </p:txBody>
+      </p:sp>
+      <p:sp>
+        <p:nvSpPr>
           <p:cNvPr id="47" name="Text 36"/>
           <p:cNvSpPr txBox="1"/>
           <p:nvPr/>
         </p:nvSpPr>
         <p:spPr>
           <a:xfrm>
-            <a:off x="731520" y="5669280"/>
-            <a:ext cx="822960" cy="777240"/>
-          </a:xfrm>
-          <a:prstGeom prst="rect">
-            <a:avLst/>
-          </a:prstGeom>
-          <a:noFill/>
-          <a:ln/>
-        </p:spPr>
-        <p:txBody>
-          <a:bodyPr wrap="square" lIns="0" tIns="0" rIns="0" bIns="0" rtlCol="0" anchor="ctr"/>
-          <a:lstStyle/>
-          <a:p>
-            <a:pPr indent="0" marL="0">
-              <a:buNone/>
-            </a:pPr>
-            <a:r>
-              <a:rPr lang="en-US" sz="1100" b="1" dirty="0">
-                <a:solidFill>
-                  <a:srgbClr val="B9BEC6"/>
-                </a:solidFill>
-                <a:latin typeface="Meiryo" pitchFamily="34" charset="0"/>
-                <a:ea typeface="Meiryo" pitchFamily="34" charset="-122"/>
-                <a:cs typeface="Meiryo" pitchFamily="34" charset="-120"/>
-              </a:rPr>
-              <a:t>合言葉</a:t>
-            </a:r>
-            <a:endParaRPr lang="en-US" sz="1100" dirty="0"/>
-          </a:p>
-        </p:txBody>
-      </p:sp>
-      <p:sp>
-        <p:nvSpPr>
-          <p:cNvPr id="48" name="Text 37"/>
-          <p:cNvSpPr txBox="1"/>
-          <p:nvPr/>
-        </p:nvSpPr>
-        <p:spPr>
-          <a:xfrm>
             <a:off x="1463040" y="5669280"/>
             <a:ext cx="4206240" cy="777240"/>
           </a:xfrm>
@@ -4888,7 +4810,7 @@
       </p:sp>
       <p:sp>
         <p:nvSpPr>
-          <p:cNvPr id="49" name="Text 38"/>
+          <p:cNvPr id="48" name="Text 37"/>
           <p:cNvSpPr txBox="1"/>
           <p:nvPr/>
         </p:nvSpPr>

</xml_diff>